<commit_message>
strip background increase contrast
</commit_message>
<xml_diff>
--- a/concepts/randomness/.graphics/sample plots.pptx
+++ b/concepts/randomness/.graphics/sample plots.pptx
@@ -31,7 +31,7 @@
       </p:grpSpPr>
       <p:sp>
         <p:nvSpPr>
-          <p:cNvPr id="5" name="PlaceHolder 1"/>
+          <p:cNvPr id="4" name="PlaceHolder 1"/>
           <p:cNvSpPr>
             <a:spLocks noGrp="1"/>
           </p:cNvSpPr>
@@ -42,7 +42,7 @@
         <p:spPr>
           <a:xfrm>
             <a:off x="504000" y="226080"/>
-            <a:ext cx="9071280" cy="946080"/>
+            <a:ext cx="9070920" cy="945720"/>
           </a:xfrm>
           <a:prstGeom prst="rect">
             <a:avLst/>
@@ -71,7 +71,7 @@
       </p:sp>
       <p:sp>
         <p:nvSpPr>
-          <p:cNvPr id="6" name="PlaceHolder 2"/>
+          <p:cNvPr id="5" name="PlaceHolder 2"/>
           <p:cNvSpPr>
             <a:spLocks noGrp="1"/>
           </p:cNvSpPr>
@@ -143,7 +143,7 @@
         <p:txBody>
           <a:bodyPr/>
           <a:p>
-            <a:fld id="{E92DFA0D-D1AD-4592-9C72-251C3AD54E77}" type="slidenum">
+            <a:fld id="{F11E9E08-CE4A-4367-8419-B041F35314BB}" type="slidenum">
               <a:t>&lt;#&gt;</a:t>
             </a:fld>
           </a:p>
@@ -205,7 +205,7 @@
         <p:spPr>
           <a:xfrm>
             <a:off x="504000" y="226080"/>
-            <a:ext cx="9071280" cy="946080"/>
+            <a:ext cx="9070920" cy="945720"/>
           </a:xfrm>
           <a:prstGeom prst="rect">
             <a:avLst/>
@@ -254,7 +254,7 @@
         <p:spPr>
           <a:xfrm>
             <a:off x="3447360" y="5165280"/>
-            <a:ext cx="3194640" cy="390240"/>
+            <a:ext cx="3194280" cy="389880"/>
           </a:xfrm>
           <a:prstGeom prst="rect">
             <a:avLst/>
@@ -326,7 +326,7 @@
         <p:spPr>
           <a:xfrm>
             <a:off x="7227360" y="5165280"/>
-            <a:ext cx="2347920" cy="390240"/>
+            <a:ext cx="2347560" cy="389880"/>
           </a:xfrm>
           <a:prstGeom prst="rect">
             <a:avLst/>
@@ -367,7 +367,7 @@
                 <a:tab algn="l" pos="0"/>
               </a:tabLst>
             </a:pPr>
-            <a:fld id="{4D4E2B23-3882-481E-9125-D1D01A6E73D1}" type="slidenum">
+            <a:fld id="{382B70DF-9084-4DEA-AB93-9D73E22B91C1}" type="slidenum">
               <a:rPr b="0" lang="en-US" sz="1400" spc="-1" strike="noStrike">
                 <a:solidFill>
                   <a:srgbClr val="000000"/>
@@ -398,7 +398,7 @@
         <p:spPr>
           <a:xfrm>
             <a:off x="504000" y="5165280"/>
-            <a:ext cx="2347920" cy="390240"/>
+            <a:ext cx="2347560" cy="389880"/>
           </a:xfrm>
           <a:prstGeom prst="rect">
             <a:avLst/>
@@ -441,231 +441,6 @@
                 <a:srgbClr val="000000"/>
               </a:solidFill>
               <a:latin typeface="Times New Roman"/>
-            </a:endParaRPr>
-          </a:p>
-        </p:txBody>
-      </p:sp>
-      <p:sp>
-        <p:nvSpPr>
-          <p:cNvPr id="4" name="PlaceHolder 5"/>
-          <p:cNvSpPr>
-            <a:spLocks noGrp="1"/>
-          </p:cNvSpPr>
-          <p:nvPr>
-            <p:ph type="body"/>
-          </p:nvPr>
-        </p:nvSpPr>
-        <p:spPr>
-          <a:xfrm>
-            <a:off x="504000" y="1326600"/>
-            <a:ext cx="9072000" cy="3288600"/>
-          </a:xfrm>
-          <a:prstGeom prst="rect">
-            <a:avLst/>
-          </a:prstGeom>
-          <a:noFill/>
-          <a:ln w="0">
-            <a:noFill/>
-          </a:ln>
-        </p:spPr>
-        <p:txBody>
-          <a:bodyPr lIns="0" rIns="0" tIns="0" bIns="0" anchor="t">
-            <a:normAutofit/>
-          </a:bodyPr>
-          <a:p>
-            <a:pPr marL="432000" indent="-324000">
-              <a:spcBef>
-                <a:spcPts val="1417"/>
-              </a:spcBef>
-              <a:buClr>
-                <a:srgbClr val="000000"/>
-              </a:buClr>
-              <a:buSzPct val="45000"/>
-              <a:buFont typeface="Wingdings" charset="2"/>
-              <a:buChar char=""/>
-            </a:pPr>
-            <a:r>
-              <a:rPr b="0" lang="en-US" sz="3200" spc="-1" strike="noStrike">
-                <a:solidFill>
-                  <a:srgbClr val="000000"/>
-                </a:solidFill>
-                <a:latin typeface="Arial"/>
-              </a:rPr>
-              <a:t>Click to edit the outline text format</a:t>
-            </a:r>
-            <a:endParaRPr b="0" lang="en-US" sz="3200" spc="-1" strike="noStrike">
-              <a:solidFill>
-                <a:srgbClr val="000000"/>
-              </a:solidFill>
-              <a:latin typeface="Arial"/>
-            </a:endParaRPr>
-          </a:p>
-          <a:p>
-            <a:pPr lvl="1" marL="864000" indent="-324000">
-              <a:spcBef>
-                <a:spcPts val="1134"/>
-              </a:spcBef>
-              <a:buClr>
-                <a:srgbClr val="000000"/>
-              </a:buClr>
-              <a:buSzPct val="75000"/>
-              <a:buFont typeface="Symbol" charset="2"/>
-              <a:buChar char=""/>
-            </a:pPr>
-            <a:r>
-              <a:rPr b="0" lang="en-US" sz="2800" spc="-1" strike="noStrike">
-                <a:solidFill>
-                  <a:srgbClr val="000000"/>
-                </a:solidFill>
-                <a:latin typeface="Arial"/>
-              </a:rPr>
-              <a:t>Second Outline Level</a:t>
-            </a:r>
-            <a:endParaRPr b="0" lang="en-US" sz="2800" spc="-1" strike="noStrike">
-              <a:solidFill>
-                <a:srgbClr val="000000"/>
-              </a:solidFill>
-              <a:latin typeface="Arial"/>
-            </a:endParaRPr>
-          </a:p>
-          <a:p>
-            <a:pPr lvl="2" marL="1296000" indent="-288000">
-              <a:spcBef>
-                <a:spcPts val="850"/>
-              </a:spcBef>
-              <a:buClr>
-                <a:srgbClr val="000000"/>
-              </a:buClr>
-              <a:buSzPct val="45000"/>
-              <a:buFont typeface="Wingdings" charset="2"/>
-              <a:buChar char=""/>
-            </a:pPr>
-            <a:r>
-              <a:rPr b="0" lang="en-US" sz="2400" spc="-1" strike="noStrike">
-                <a:solidFill>
-                  <a:srgbClr val="000000"/>
-                </a:solidFill>
-                <a:latin typeface="Arial"/>
-              </a:rPr>
-              <a:t>Third Outline Level</a:t>
-            </a:r>
-            <a:endParaRPr b="0" lang="en-US" sz="2400" spc="-1" strike="noStrike">
-              <a:solidFill>
-                <a:srgbClr val="000000"/>
-              </a:solidFill>
-              <a:latin typeface="Arial"/>
-            </a:endParaRPr>
-          </a:p>
-          <a:p>
-            <a:pPr lvl="3" marL="1728000" indent="-216000">
-              <a:spcBef>
-                <a:spcPts val="567"/>
-              </a:spcBef>
-              <a:buClr>
-                <a:srgbClr val="000000"/>
-              </a:buClr>
-              <a:buSzPct val="75000"/>
-              <a:buFont typeface="Symbol" charset="2"/>
-              <a:buChar char=""/>
-            </a:pPr>
-            <a:r>
-              <a:rPr b="0" lang="en-US" sz="2000" spc="-1" strike="noStrike">
-                <a:solidFill>
-                  <a:srgbClr val="000000"/>
-                </a:solidFill>
-                <a:latin typeface="Arial"/>
-              </a:rPr>
-              <a:t>Fourth Outline Level</a:t>
-            </a:r>
-            <a:endParaRPr b="0" lang="en-US" sz="2000" spc="-1" strike="noStrike">
-              <a:solidFill>
-                <a:srgbClr val="000000"/>
-              </a:solidFill>
-              <a:latin typeface="Arial"/>
-            </a:endParaRPr>
-          </a:p>
-          <a:p>
-            <a:pPr lvl="4" marL="2160000" indent="-216000">
-              <a:spcBef>
-                <a:spcPts val="283"/>
-              </a:spcBef>
-              <a:buClr>
-                <a:srgbClr val="000000"/>
-              </a:buClr>
-              <a:buSzPct val="45000"/>
-              <a:buFont typeface="Wingdings" charset="2"/>
-              <a:buChar char=""/>
-            </a:pPr>
-            <a:r>
-              <a:rPr b="0" lang="en-US" sz="2000" spc="-1" strike="noStrike">
-                <a:solidFill>
-                  <a:srgbClr val="000000"/>
-                </a:solidFill>
-                <a:latin typeface="Arial"/>
-              </a:rPr>
-              <a:t>Fifth Outline Level</a:t>
-            </a:r>
-            <a:endParaRPr b="0" lang="en-US" sz="2000" spc="-1" strike="noStrike">
-              <a:solidFill>
-                <a:srgbClr val="000000"/>
-              </a:solidFill>
-              <a:latin typeface="Arial"/>
-            </a:endParaRPr>
-          </a:p>
-          <a:p>
-            <a:pPr lvl="5" marL="2592000" indent="-216000">
-              <a:spcBef>
-                <a:spcPts val="283"/>
-              </a:spcBef>
-              <a:buClr>
-                <a:srgbClr val="000000"/>
-              </a:buClr>
-              <a:buSzPct val="45000"/>
-              <a:buFont typeface="Wingdings" charset="2"/>
-              <a:buChar char=""/>
-            </a:pPr>
-            <a:r>
-              <a:rPr b="0" lang="en-US" sz="2000" spc="-1" strike="noStrike">
-                <a:solidFill>
-                  <a:srgbClr val="000000"/>
-                </a:solidFill>
-                <a:latin typeface="Arial"/>
-              </a:rPr>
-              <a:t>Sixth Outline Level</a:t>
-            </a:r>
-            <a:endParaRPr b="0" lang="en-US" sz="2000" spc="-1" strike="noStrike">
-              <a:solidFill>
-                <a:srgbClr val="000000"/>
-              </a:solidFill>
-              <a:latin typeface="Arial"/>
-            </a:endParaRPr>
-          </a:p>
-          <a:p>
-            <a:pPr lvl="6" marL="3024000" indent="-216000">
-              <a:spcBef>
-                <a:spcPts val="283"/>
-              </a:spcBef>
-              <a:buClr>
-                <a:srgbClr val="000000"/>
-              </a:buClr>
-              <a:buSzPct val="45000"/>
-              <a:buFont typeface="Wingdings" charset="2"/>
-              <a:buChar char=""/>
-            </a:pPr>
-            <a:r>
-              <a:rPr b="0" lang="en-US" sz="2000" spc="-1" strike="noStrike">
-                <a:solidFill>
-                  <a:srgbClr val="000000"/>
-                </a:solidFill>
-                <a:latin typeface="Arial"/>
-              </a:rPr>
-              <a:t>Seventh Outline Level</a:t>
-            </a:r>
-            <a:endParaRPr b="0" lang="en-US" sz="2000" spc="-1" strike="noStrike">
-              <a:solidFill>
-                <a:srgbClr val="000000"/>
-              </a:solidFill>
-              <a:latin typeface="Arial"/>
             </a:endParaRPr>
           </a:p>
         </p:txBody>
@@ -698,14 +473,14 @@
       </p:grpSpPr>
       <p:sp>
         <p:nvSpPr>
-          <p:cNvPr id="7" name=""/>
+          <p:cNvPr id="6" name=""/>
           <p:cNvSpPr/>
           <p:nvPr/>
         </p:nvSpPr>
         <p:spPr>
           <a:xfrm>
             <a:off x="5029560" y="457200"/>
-            <a:ext cx="4800240" cy="5028840"/>
+            <a:ext cx="4799880" cy="5028480"/>
           </a:xfrm>
           <a:prstGeom prst="rect">
             <a:avLst/>
@@ -747,7 +522,7 @@
       </p:sp>
       <p:pic>
         <p:nvPicPr>
-          <p:cNvPr id="8" name="" descr=""/>
+          <p:cNvPr id="7" name="" descr=""/>
           <p:cNvPicPr/>
           <p:nvPr/>
         </p:nvPicPr>
@@ -757,8 +532,8 @@
         </p:blipFill>
         <p:spPr>
           <a:xfrm>
-            <a:off x="228600" y="685800"/>
-            <a:ext cx="3737880" cy="4070520"/>
+            <a:off x="5443560" y="730080"/>
+            <a:ext cx="4157280" cy="4527360"/>
           </a:xfrm>
           <a:prstGeom prst="rect">
             <a:avLst/>
@@ -770,7 +545,7 @@
       </p:pic>
       <p:pic>
         <p:nvPicPr>
-          <p:cNvPr id="9" name="" descr=""/>
+          <p:cNvPr id="8" name="" descr=""/>
           <p:cNvPicPr/>
           <p:nvPr/>
         </p:nvPicPr>
@@ -780,8 +555,8 @@
         </p:blipFill>
         <p:spPr>
           <a:xfrm>
-            <a:off x="5443560" y="730080"/>
-            <a:ext cx="4157640" cy="4527720"/>
+            <a:off x="209880" y="457200"/>
+            <a:ext cx="4618440" cy="5029200"/>
           </a:xfrm>
           <a:prstGeom prst="rect">
             <a:avLst/>

</xml_diff>